<commit_message>
docs: English defence presentation, keep Russian version as _RU
Co-Authored-By: Claude Opus 5.5 <noreply@anthropic.com>
</commit_message>
<xml_diff>
--- a/docs/Defense_Presentation.pptx
+++ b/docs/Defense_Presentation.pptx
@@ -136,7 +136,7 @@
                   <a:srgbClr val="5E6B63"/>
                 </a:solidFill>
               </a:rPr>
-              <a:t>Тестов на лабораторную</a:t>
+              <a:t>Tests per lab</a:t>
             </a:r>
           </a:p>
         </c:rich>
@@ -158,7 +158,7 @@
               <c:strCache>
                 <c:ptCount val="1"/>
                 <c:pt idx="0">
-                  <c:v>Тесты</c:v>
+                  <c:v>Tests</c:v>
                 </c:pt>
               </c:strCache>
             </c:strRef>
@@ -174,22 +174,22 @@
               <c:strCache>
                 <c:ptCount val="6"/>
                 <c:pt idx="0">
-                  <c:v>Лаб. 1</c:v>
+                  <c:v>Lab 1</c:v>
                 </c:pt>
                 <c:pt idx="1">
-                  <c:v>Лаб. 2</c:v>
+                  <c:v>Lab 2</c:v>
                 </c:pt>
                 <c:pt idx="2">
-                  <c:v>Лаб. 3</c:v>
+                  <c:v>Lab 3</c:v>
                 </c:pt>
                 <c:pt idx="3">
-                  <c:v>Лаб. 4</c:v>
+                  <c:v>Lab 4</c:v>
                 </c:pt>
                 <c:pt idx="4">
-                  <c:v>Лаб. 5</c:v>
+                  <c:v>Lab 5</c:v>
                 </c:pt>
                 <c:pt idx="5">
-                  <c:v>Лаб. 6</c:v>
+                  <c:v>Lab 6</c:v>
                 </c:pt>
               </c:strCache>
             </c:strRef>
@@ -711,7 +711,7 @@
           <a:lstStyle/>
           <a:p>
             <a:r>
-              <a:t>Здравствуйте. Я представляю итоговый учебный проект по дисциплине «Разработка веб-приложений на Spring». Это одно приложение — каталог библиотеки, — в котором собраны темы и индивидуальные варианты всех шести лабораторных работ.</a:t>
+              <a:t>Good afternoon. I am presenting the final educational project for the course Web Application Development with Spring Framework. It is one application, a library catalogue, which combines the topics and the individual variants of all six laboratory works.</a:t>
             </a:r>
           </a:p>
         </p:txBody>
@@ -781,7 +781,7 @@
           <a:lstStyle/>
           <a:p>
             <a:r>
-              <a:t>Главное отличие итогового проекта от набора лабораторных — связи. Конфигурация управляет уведомлениями и кэшем. Аспекты оборачивают все операции каталога. Валидация из шестой лабораторной защищает и REST API, а IllegalArgumentException из четвёртой теперь превращается в 400, а не в 500.</a:t>
+              <a:t>The main difference between the final project and a set of labs is the connections. Configuration controls notifications and the cache. Aspects wrap every catalogue operation. Validation from lab 6 also protects the REST API, and the IllegalArgumentException from lab 4 now becomes 400 instead of 500.</a:t>
             </a:r>
           </a:p>
         </p:txBody>
@@ -851,7 +851,7 @@
           <a:lstStyle/>
           <a:p>
             <a:r>
-              <a:t>Чтобы защита не зависела от скриншотов, все эксперименты из отчётов оформлены как интеграционные тесты MockMvc. Их 17, они проверяют коды ответа, ошибки валидации, русские сообщения, прокси, самовызов, профиль dev. Команда mvnw test — и всё зелёное.</a:t>
+              <a:t>So that the defence does not depend on screenshots, every experiment from the reports is written as a MockMvc integration test. There are 17 of them: they check status codes, validation errors, Russian messages, the proxy, self-invocation and the dev profile. One command, mvnw test, and everything is green.</a:t>
             </a:r>
           </a:p>
         </p:txBody>
@@ -921,7 +921,7 @@
           <a:lstStyle/>
           <a:p>
             <a:r>
-              <a:t>Демонстрация занимает около пяти минут. Сначала тесты, затем стартовая страница с карточками по лабораторным, форма на русском с ошибками, корректное добавление книги и лог аспектов в консоли, эксперимент с самовызовом, две разные 404 и перезапуск с профилем dev.</a:t>
+              <a:t>The demonstration takes about five minutes. First the tests, then the start page with a card for each lab, the Russian form with errors, adding a book correctly and the aspect log in the console, the self-invocation experiment, two different 404 responses and a restart with the dev profile.</a:t>
             </a:r>
           </a:p>
         </p:txBody>
@@ -991,7 +991,7 @@
           <a:lstStyle/>
           <a:p>
             <a:r>
-              <a:t>Здесь собраны самые частые вопросы по всем лабораторным. Полный список с ответами — в docs/DEFENSE.md.</a:t>
+              <a:t>These are the most frequent questions across all labs. The full list with answers is in docs/DEFENSE.md.</a:t>
             </a:r>
           </a:p>
         </p:txBody>
@@ -1061,7 +1061,7 @@
           <a:lstStyle/>
           <a:p>
             <a:r>
-              <a:t>Итог: шесть лабораторных работ собраны в одно работающее приложение, где каждая тема — слой системы, индивидуальные варианты реализованы и связаны между собой, а эксперименты проверяются тестами. Спасибо за внимание, готов ответить на вопросы.</a:t>
+              <a:t>To sum up: six laboratory works are combined into one working application where each topic is a layer of the system, the individual variants are implemented and connected to each other, and the experiments are verified by tests. Thank you for your attention, I am ready to answer your questions.</a:t>
             </a:r>
           </a:p>
         </p:txBody>
@@ -1131,7 +1131,7 @@
           <a:lstStyle/>
           <a:p>
             <a:r>
-              <a:t>Все лабораторные делались в одном репозитории spring-lab-01, но каждая — отдельной веткой и отдельной демонстрацией. В итоговом проекте они превращены в слои одного каталога библиотеки: REST и MVC — это вход, IoC — сборка, конфигурация — параметры, AOP — сквозная функциональность, формы — пользовательский интерфейс. Всё работает на одном BookService, и каждый эксперимент из отчётов воспроизводится автоматическим тестом.</a:t>
+              <a:t>All the labs were done in one repository, spring-lab-01, but each one on its own branch and as a separate demonstration. In the final project they become layers of one library catalogue: REST and MVC are the entry point, IoC assembles the application, configuration supplies the parameters, AOP adds cross-cutting behaviour and forms are the user interface. Everything works on one BookService, and every experiment from the reports is reproduced by an automated test.</a:t>
             </a:r>
           </a:p>
         </p:txBody>
@@ -1201,7 +1201,7 @@
           <a:lstStyle/>
           <a:p>
             <a:r>
-              <a:t>Запрос попадает в DispatcherServlet. LocaleChangeInterceptor из шестой лабораторной выбирает язык. REST-контроллеры из первой, третьей и пятой лабораторных возвращают JSON, страничный контроллер — имя шаблона Thymeleaf. Ошибки разводятся двумя ControllerAdvice. Ниже — CGLIB-прокси BookService, через который проходят четыре аспекта из четвёртой. Сам сервис использует репозиторий, уведомления из второй и кэш цитат, параметры которого задаёт конфигурация из третьей лабораторной.</a:t>
+              <a:t>A request enters the DispatcherServlet. The LocaleChangeInterceptor from lab 6 selects the language. The REST controllers from labs 1, 3 and 5 return JSON, the page controller returns a Thymeleaf view name. Errors are split between two ControllerAdvice classes. Below is the CGLIB proxy of BookService, through which the four aspects from lab 4 pass. The service itself uses the repository, the notifications from lab 2 and the citation cache, whose parameters come from the configuration of lab 3.</a:t>
             </a:r>
           </a:p>
         </p:txBody>
@@ -1271,7 +1271,7 @@
           <a:lstStyle/>
           <a:p>
             <a:r>
-              <a:t>Первая лабораторная — окружение и первый проект. В итоговом проекте от неё остались parent POM, стартер webmvc, DevTools, Maven Wrapper и HelloController. Индивидуальный вариант 7 — эндпоинт wordcount: он считает слова, символы и находит самое длинное слово. Если параметр не передан, defaultValue равен пустой строке, поэтому ответ — нули, а не ошибка 400.</a:t>
+              <a:t>Lab 1 set up the environment and the first project. From it the final project keeps the parent POM, the webmvc starter, DevTools, the Maven Wrapper and HelloController. Individual variant 7 is the wordcount endpoint: it counts words and characters and finds the longest word. If the parameter is missing, defaultValue is an empty string, so the answer is zeros instead of a 400 error.</a:t>
             </a:r>
           </a:p>
         </p:txBody>
@@ -1341,7 +1341,7 @@
           <a:lstStyle/>
           <a:p>
             <a:r>
-              <a:t>Вторая лабораторная — IoC-контейнер. Есть интерфейс Notifier и четыре реализации. Email помечен Primary, noop — Fallback, порядок в списке задаёт Order. NotificationService получает их всеми способами: через Primary, Qualifier, List и Map. Вариант 8 — HtmlNotifier, который экранирует угловые скобки. В итоговом проекте это не демо: при добавлении книги сервис рассылает уведомление через Primary-бин. Также есть @Bean для DateTimeFormatter, жизненный цикл и prototype-бин Ticket через ObjectProvider.</a:t>
+              <a:t>Lab 2 is about the IoC container. There is a Notifier interface with four implementations. Email is marked Primary, noop is Fallback, and Order defines the order in the list. NotificationService receives them in every possible way: through Primary, Qualifier, List and Map. Variant 8 is HtmlNotifier, which escapes angle brackets. In the final project this is not just a demo: when a book is added, the service sends a notification through the Primary bean. There is also a @Bean for DateTimeFormatter, the bean lifecycle and a prototype Ticket bean obtained through ObjectProvider.</a:t>
             </a:r>
           </a:p>
         </p:txBody>
@@ -1411,7 +1411,7 @@
           <a:lstStyle/>
           <a:p>
             <a:r>
-              <a:t>Третья лабораторная — внешняя конфигурация. application.yml общий, dev и prod переопределяют значения. AppProperties — это record с ConfigurationProperties и Validated: если задать retry-count 99, приложение не стартует. EnvironmentBanner показывает, что для любой комбинации профилей существует ровно один бин. Вариант 7 — app.cache. В отчёте он только выводился в JSON, а здесь CitationCache реально кэширует цитаты по ttl и max-entries. Приоритет: командная строка выше системного свойства, выше переменной окружения, выше файлов.</a:t>
+              <a:t>Lab 3 is about external configuration. application.yml holds the shared values, dev and prod override them. AppProperties is a record with ConfigurationProperties and Validated: with retry-count set to 99 the application does not start. EnvironmentBanner shows that for any combination of profiles exactly one bean exists. Variant 7 is app.cache. In the report it was only printed in JSON; here CitationCache really caches citations by ttl and max-entries. Precedence: a command-line argument beats a JVM system property, which beats an environment variable, which beats the files.</a:t>
             </a:r>
           </a:p>
         </p:txBody>
@@ -1481,7 +1481,7 @@
           <a:lstStyle/>
           <a:p>
             <a:r>
-              <a:t>Четвёртая лабораторная — AOP. Pointcuts — библиотека именованных срезов: публичные методы пакета service. Аспекты упорядочены: аудит снаружи, затем логирование, затем замер времени. Аудит работает только для методов с аннотацией Audited. Сервис — CGLIB-прокси, это видно на /api/system/proxy. Самовызов: если deleteBulk вызывает this.delete, аудита нет; через self — по записи на каждый id. Вариант 8 — трассировка вызовов: вызов citation, внутри которого CitationCache.get, даёт реальный вложенный отступ.</a:t>
+              <a:t>Lab 4 is AOP. Pointcuts is a library of named pointcuts: public methods of the service package. The aspects are ordered: audit is the outermost, then logging, then timing. Auditing applies only to methods carrying the Audited annotation. The service is a CGLIB proxy, which /api/system/proxy shows. Self-invocation: if deleteBulk calls this.delete, there is no audit; through self there is one record per id. Variant 8 is call tracing: a citation call, which calls CitationCache.get inside, produces a real nested indentation.</a:t>
             </a:r>
           </a:p>
         </p:txBody>
@@ -1551,7 +1551,7 @@
           <a:lstStyle/>
           <a:p>
             <a:r>
-              <a:t>Пятую лабораторную выполнял мой напарник Бекбаев Гибрат; в итоговом проекте она стала основой каталога. Доменный record Book, in-memory репозиторий, сервис, REST-контроллер с пятью операциями и страничный контроллер с Thymeleaf. Важный эксперимент — коды ответа: каждый из 400, 404, 405, 415, 406 указывает, какая часть сопоставления не совпала. Вариант 6 — цитата в text/plain; при Accept application/json — 406.</a:t>
+              <a:t>Lab 5 was done by my partner Gibrat Bekbaev; in the final project it became the base of the catalogue. A Book domain record, an in-memory repository, a service, a REST controller with five operations and a page controller with Thymeleaf. The key experiment is the status codes: each of 400, 404, 405, 415 and 406 points to the part of the mapping that did not match. Variant 6 is a citation as text/plain; with Accept application/json the answer is 406.</a:t>
             </a:r>
           </a:p>
         </p:txBody>
@@ -1621,7 +1621,7 @@
           <a:lstStyle/>
           <a:p>
             <a:r>
-              <a:t>Шестая лабораторная — формы. BookForm — отдельный изменяемый класс без id, это защита от mass assignment. Путь сообщения об ошибке: биндер заполняет форму, Valid запускает Hibernate Validator, ключ из фигурных скобок разрешается через MessageSource для текущей локали, ошибка попадает в BindingResult, контроллер возвращает форму, а th:errors выводит текст. Своё ограничение NoDigits, две ControllerAdvice для страниц и API. Вариант 7 — дата публикации, формат которой зависит от языка. В итоговом проекте те же ограничения проверяют и JSON в REST API.</a:t>
+              <a:t>Lab 6 is about forms. BookForm is a separate mutable class without an id, which protects from mass assignment. The path of an error message: the binder fills the form, Valid runs Hibernate Validator, the key in braces is resolved through the MessageSource for the current locale, the error goes into BindingResult, the controller returns the form and th:errors prints the text. There is a custom NoDigits constraint and two ControllerAdvice classes for pages and the API. Variant 7 is the publication date, whose format depends on the language. In the final project the same constraints also validate the JSON of the REST API.</a:t>
             </a:r>
           </a:p>
         </p:txBody>
@@ -4761,7 +4761,7 @@
                 </a:solidFill>
                 <a:latin typeface="Calibri"/>
               </a:rPr>
-              <a:t>Итоговый учебный проект: шесть лабораторных работ — одно Spring Boot приложение</a:t>
+              <a:t>Final educational project: six laboratory works in one Spring Boot application</a:t>
             </a:r>
           </a:p>
         </p:txBody>
@@ -4800,7 +4800,7 @@
                 </a:solidFill>
                 <a:latin typeface="Calibri"/>
               </a:rPr>
-              <a:t>Бектурсын Куат</a:t>
+              <a:t>Kuat Bektursyn</a:t>
             </a:r>
           </a:p>
           <a:p>
@@ -4816,7 +4816,7 @@
                 </a:solidFill>
                 <a:latin typeface="Calibri"/>
               </a:rPr>
-              <a:t>Группа IT1-2409IS  ·  RWPSF 3305 — Web Application Development with Spring Framework</a:t>
+              <a:t>Group IT1-2409IS  ·  RWPSF 3305 — Web Application Development with Spring Framework</a:t>
             </a:r>
           </a:p>
           <a:p>
@@ -4832,7 +4832,7 @@
                 </a:solidFill>
                 <a:latin typeface="Calibri"/>
               </a:rPr>
-              <a:t>IITU, Алматы, 2026</a:t>
+              <a:t>IITU, Almaty, 2026</a:t>
             </a:r>
           </a:p>
         </p:txBody>
@@ -4936,7 +4936,7 @@
                 </a:solidFill>
                 <a:latin typeface="Cambria"/>
               </a:rPr>
-              <a:t>Не рядом, а вместе: как связаны лабораторные</a:t>
+              <a:t>Not side by side, but together: how labs connect</a:t>
             </a:r>
           </a:p>
         </p:txBody>
@@ -4975,7 +4975,7 @@
                 </a:solidFill>
                 <a:latin typeface="Calibri"/>
               </a:rPr>
-              <a:t>Library Portal  ·  RWPSF 3305  ·  Бектурсын Куат</a:t>
+              <a:t>Library Portal  ·  RWPSF 3305  ·  Kuat Bektursyn</a:t>
             </a:r>
           </a:p>
         </p:txBody>
@@ -5184,7 +5184,7 @@
                 </a:solidFill>
                 <a:latin typeface="Calibri"/>
               </a:rPr>
-              <a:t>Уведомления о новой книге</a:t>
+              <a:t>New book notifications</a:t>
             </a:r>
           </a:p>
         </p:txBody>
@@ -5223,7 +5223,7 @@
                 </a:solidFill>
                 <a:latin typeface="Calibri"/>
               </a:rPr>
-              <a:t>BookService.create() вызывает @Primary EmailNotifier</a:t>
+              <a:t>BookService.create() calls the @Primary EmailNotifier</a:t>
             </a:r>
           </a:p>
         </p:txBody>
@@ -5393,7 +5393,7 @@
                 </a:solidFill>
                 <a:latin typeface="Calibri"/>
               </a:rPr>
-              <a:t>Почта зависит от профиля</a:t>
+              <a:t>Mail depends on the profile</a:t>
             </a:r>
           </a:p>
         </p:txBody>
@@ -5432,7 +5432,7 @@
                 </a:solidFill>
                 <a:latin typeface="Calibri"/>
               </a:rPr>
-              <a:t>dev: mail выключен · prod: retry-count = 5</a:t>
+              <a:t>dev: mail disabled · prod: retry-count = 5</a:t>
             </a:r>
           </a:p>
         </p:txBody>
@@ -5602,7 +5602,7 @@
                 </a:solidFill>
                 <a:latin typeface="Calibri"/>
               </a:rPr>
-              <a:t>Кэш цитат по app.cache</a:t>
+              <a:t>Citation cache from app.cache</a:t>
             </a:r>
           </a:p>
         </p:txBody>
@@ -5641,7 +5641,7 @@
                 </a:solidFill>
                 <a:latin typeface="Calibri"/>
               </a:rPr>
-              <a:t>1 мин / 100 записей, под dev — 30 с / 50</a:t>
+              <a:t>1 min / 100 entries, under dev — 30 s / 50</a:t>
             </a:r>
           </a:p>
         </p:txBody>
@@ -5772,7 +5772,7 @@
                 </a:solidFill>
                 <a:latin typeface="Calibri"/>
               </a:rPr>
-              <a:t>4 → все</a:t>
+              <a:t>4 → all</a:t>
             </a:r>
           </a:p>
         </p:txBody>
@@ -5811,7 +5811,7 @@
                 </a:solidFill>
                 <a:latin typeface="Calibri"/>
               </a:rPr>
-              <a:t>Каждая операция обёрнута</a:t>
+              <a:t>Every operation is wrapped</a:t>
             </a:r>
           </a:p>
         </p:txBody>
@@ -5850,7 +5850,7 @@
                 </a:solidFill>
                 <a:latin typeface="Calibri"/>
               </a:rPr>
-              <a:t>Audit · Log · Time · Trace на всём сервисном слое</a:t>
+              <a:t>Audit · Log · Time · Trace on the whole service layer</a:t>
             </a:r>
           </a:p>
         </p:txBody>
@@ -6020,7 +6020,7 @@
                 </a:solidFill>
                 <a:latin typeface="Calibri"/>
               </a:rPr>
-              <a:t>Валидация JSON в API</a:t>
+              <a:t>JSON validation in the API</a:t>
             </a:r>
           </a:p>
         </p:txBody>
@@ -6059,7 +6059,7 @@
                 </a:solidFill>
                 <a:latin typeface="Calibri"/>
               </a:rPr>
-              <a:t>BookRequest: те же ограничения и сообщения → 400</a:t>
+              <a:t>BookRequest: the same constraints and messages → 400</a:t>
             </a:r>
           </a:p>
         </p:txBody>
@@ -6229,7 +6229,7 @@
                 </a:solidFill>
                 <a:latin typeface="Calibri"/>
               </a:rPr>
-              <a:t>Ошибка клиента — 400</a:t>
+              <a:t>Client error is 400</a:t>
             </a:r>
           </a:p>
         </p:txBody>
@@ -6268,7 +6268,7 @@
                 </a:solidFill>
                 <a:latin typeface="Calibri"/>
               </a:rPr>
-              <a:t>delete(0): @AfterThrowing, аудит failure, ProblemDetail</a:t>
+              <a:t>delete(0): @AfterThrowing, audit failure, ProblemDetail</a:t>
             </a:r>
           </a:p>
         </p:txBody>
@@ -6333,7 +6333,7 @@
                 </a:solidFill>
                 <a:latin typeface="Cambria"/>
               </a:rPr>
-              <a:t>Каждый эксперимент — автоматический тест</a:t>
+              <a:t>Every experiment is an automated test</a:t>
             </a:r>
           </a:p>
         </p:txBody>
@@ -6372,7 +6372,7 @@
                 </a:solidFill>
                 <a:latin typeface="Calibri"/>
               </a:rPr>
-              <a:t>Library Portal  ·  RWPSF 3305  ·  Бектурсын Куат</a:t>
+              <a:t>Library Portal  ·  RWPSF 3305  ·  Kuat Bektursyn</a:t>
             </a:r>
           </a:p>
         </p:txBody>
@@ -6618,7 +6618,7 @@
                 </a:solidFill>
                 <a:latin typeface="Calibri"/>
               </a:rPr>
-              <a:t>ошибки формы на EN и RU, flash + redirect</a:t>
+              <a:t>form errors in EN and RU, flash + redirect</a:t>
             </a:r>
           </a:p>
           <a:p>
@@ -6639,7 +6639,7 @@
                 </a:solidFill>
                 <a:latin typeface="Calibri"/>
               </a:rPr>
-              <a:t>CGLIB-прокси и самовызов: 0 vs 2 записи</a:t>
+              <a:t>CGLIB proxy and self-invocation: 0 vs 2 records</a:t>
             </a:r>
           </a:p>
           <a:p>
@@ -6660,7 +6660,7 @@
                 </a:solidFill>
                 <a:latin typeface="Calibri"/>
               </a:rPr>
-              <a:t>профиль dev: порт 8081, ttl PT30S</a:t>
+              <a:t>dev profile: port 8081, ttl PT30S</a:t>
             </a:r>
           </a:p>
         </p:txBody>
@@ -6725,7 +6725,7 @@
                 </a:solidFill>
                 <a:latin typeface="Cambria"/>
               </a:rPr>
-              <a:t>Сценарий демонстрации</a:t>
+              <a:t>Demonstration script</a:t>
             </a:r>
           </a:p>
         </p:txBody>
@@ -6764,7 +6764,7 @@
                 </a:solidFill>
                 <a:latin typeface="Calibri"/>
               </a:rPr>
-              <a:t>Library Portal  ·  RWPSF 3305  ·  Бектурсын Куат</a:t>
+              <a:t>Library Portal  ·  RWPSF 3305  ·  Kuat Bektursyn</a:t>
             </a:r>
           </a:p>
         </p:txBody>
@@ -6934,7 +6934,7 @@
                 </a:solidFill>
                 <a:latin typeface="Calibri"/>
               </a:rPr>
-              <a:t>17 тестов зелёные</a:t>
+              <a:t>17 tests are green</a:t>
             </a:r>
           </a:p>
         </p:txBody>
@@ -7065,7 +7065,7 @@
                 </a:solidFill>
                 <a:latin typeface="Calibri"/>
               </a:rPr>
-              <a:t>стартовая страница: ссылки по каждой лабе</a:t>
+              <a:t>start page: links for every lab</a:t>
             </a:r>
           </a:p>
         </p:txBody>
@@ -7196,7 +7196,7 @@
                 </a:solidFill>
                 <a:latin typeface="Calibri"/>
               </a:rPr>
-              <a:t>все ошибки валидации на русском</a:t>
+              <a:t>all validation errors in Russian</a:t>
             </a:r>
           </a:p>
         </p:txBody>
@@ -7288,7 +7288,7 @@
                 </a:solidFill>
                 <a:latin typeface="Courier New"/>
               </a:rPr>
-              <a:t>Корректная форма → F5</a:t>
+              <a:t>Valid form → F5</a:t>
             </a:r>
           </a:p>
         </p:txBody>
@@ -7327,7 +7327,7 @@
                 </a:solidFill>
                 <a:latin typeface="Calibri"/>
               </a:rPr>
-              <a:t>redirect + flash, дубля нет; в логе [AUDIT] и EMAIL</a:t>
+              <a:t>redirect + flash, no duplicate; [AUDIT] and EMAIL in the log</a:t>
             </a:r>
           </a:p>
         </p:txBody>
@@ -7458,7 +7458,7 @@
                 </a:solidFill>
                 <a:latin typeface="Calibri"/>
               </a:rPr>
-              <a:t>/api/system/audit: 0 и 2 записи</a:t>
+              <a:t>/api/system/audit: 0 and 2 records</a:t>
             </a:r>
           </a:p>
         </p:txBody>
@@ -7550,7 +7550,7 @@
                 </a:solidFill>
                 <a:latin typeface="Courier New"/>
               </a:rPr>
-              <a:t>/books/999 и /api/books/999</a:t>
+              <a:t>/books/999 and /api/books/999</a:t>
             </a:r>
           </a:p>
         </p:txBody>
@@ -7589,7 +7589,7 @@
                 </a:solidFill>
                 <a:latin typeface="Calibri"/>
               </a:rPr>
-              <a:t>HTML-страница vs ProblemDetail</a:t>
+              <a:t>HTML page vs ProblemDetail</a:t>
             </a:r>
           </a:p>
         </p:txBody>
@@ -7720,7 +7720,7 @@
                 </a:solidFill>
                 <a:latin typeface="Calibri"/>
               </a:rPr>
-              <a:t>порт 8081, PT30S, DEVELOPMENT</a:t>
+              <a:t>port 8081, PT30S, DEVELOPMENT</a:t>
             </a:r>
           </a:p>
         </p:txBody>
@@ -7785,7 +7785,7 @@
                 </a:solidFill>
                 <a:latin typeface="Cambria"/>
               </a:rPr>
-              <a:t>Ключевые вопросы защиты</a:t>
+              <a:t>Key defence questions</a:t>
             </a:r>
           </a:p>
         </p:txBody>
@@ -7824,7 +7824,7 @@
                 </a:solidFill>
                 <a:latin typeface="Calibri"/>
               </a:rPr>
-              <a:t>Library Portal  ·  RWPSF 3305  ·  Бектурсын Куат</a:t>
+              <a:t>Library Portal  ·  RWPSF 3305  ·  Kuat Bektursyn</a:t>
             </a:r>
           </a:p>
         </p:txBody>
@@ -7948,7 +7948,7 @@
                 </a:solidFill>
                 <a:latin typeface="Calibri"/>
               </a:rPr>
-              <a:t>Почему внедрение через конструктор?</a:t>
+              <a:t>Why constructor injection?</a:t>
             </a:r>
           </a:p>
         </p:txBody>
@@ -7987,7 +7987,7 @@
                 </a:solidFill>
                 <a:latin typeface="Calibri"/>
               </a:rPr>
-              <a:t>final-поля, объект всегда собран, легко тестировать</a:t>
+              <a:t>final fields, the object is always complete, easy to test</a:t>
             </a:r>
           </a:p>
         </p:txBody>
@@ -8074,7 +8074,7 @@
                 </a:solidFill>
                 <a:latin typeface="Calibri"/>
               </a:rPr>
-              <a:t>Singleton с prototype внутри?</a:t>
+              <a:t>A prototype inside a singleton?</a:t>
             </a:r>
           </a:p>
         </p:txBody>
@@ -8113,7 +8113,7 @@
                 </a:solidFill>
                 <a:latin typeface="Calibri"/>
               </a:rPr>
-              <a:t>prototype создаётся один раз; новый — через ObjectProvider</a:t>
+              <a:t>created once; a fresh one only through ObjectProvider</a:t>
             </a:r>
           </a:p>
         </p:txBody>
@@ -8200,7 +8200,7 @@
                 </a:solidFill>
                 <a:latin typeface="Calibri"/>
               </a:rPr>
-              <a:t>Профиль или аргумент --?</a:t>
+              <a:t>Profile file or --argument?</a:t>
             </a:r>
           </a:p>
         </p:txBody>
@@ -8239,7 +8239,7 @@
                 </a:solidFill>
                 <a:latin typeface="Calibri"/>
               </a:rPr>
-              <a:t>аргумент командной строки: профиль — тоже лишь PropertySource</a:t>
+              <a:t>the command-line argument: a profile is just a PropertySource</a:t>
             </a:r>
           </a:p>
         </p:txBody>
@@ -8324,7 +8324,7 @@
                 </a:solidFill>
                 <a:latin typeface="Calibri"/>
               </a:rPr>
-              <a:t>Что будет без proceed()?</a:t>
+              <a:t>What if proceed() is removed?</a:t>
             </a:r>
           </a:p>
         </p:txBody>
@@ -8363,7 +8363,7 @@
                 </a:solidFill>
                 <a:latin typeface="Calibri"/>
               </a:rPr>
-              <a:t>целевой метод не выполнится</a:t>
+              <a:t>the target method is never executed</a:t>
             </a:r>
           </a:p>
         </p:txBody>
@@ -8448,7 +8448,7 @@
                 </a:solidFill>
                 <a:latin typeface="Calibri"/>
               </a:rPr>
-              <a:t>Почему самовызов не перехватывается?</a:t>
+              <a:t>Why is self-invocation not advised?</a:t>
             </a:r>
           </a:p>
         </p:txBody>
@@ -8487,7 +8487,7 @@
                 </a:solidFill>
                 <a:latin typeface="Calibri"/>
               </a:rPr>
-              <a:t>this.method() не проходит через прокси → self-ссылка</a:t>
+              <a:t>this.method() skips the proxy → use a self reference</a:t>
             </a:r>
           </a:p>
         </p:txBody>
@@ -8574,7 +8574,7 @@
                 </a:solidFill>
                 <a:latin typeface="Calibri"/>
               </a:rPr>
-              <a:t>Что значат 405 / 415 / 406?</a:t>
+              <a:t>What do 405 / 415 / 406 mean?</a:t>
             </a:r>
           </a:p>
         </p:txBody>
@@ -8613,7 +8613,7 @@
                 </a:solidFill>
                 <a:latin typeface="Calibri"/>
               </a:rPr>
-              <a:t>не совпал метод / тип тела / тип ответа</a:t>
+              <a:t>wrong method / body media type / response media type</a:t>
             </a:r>
           </a:p>
         </p:txBody>
@@ -8700,7 +8700,7 @@
                 </a:solidFill>
                 <a:latin typeface="Calibri"/>
               </a:rPr>
-              <a:t>Зачем отдельный BookForm?</a:t>
+              <a:t>Why a separate BookForm?</a:t>
             </a:r>
           </a:p>
         </p:txBody>
@@ -8739,7 +8739,7 @@
                 </a:solidFill>
                 <a:latin typeface="Calibri"/>
               </a:rPr>
-              <a:t>защита от mass assignment, ввод сохраняется</a:t>
+              <a:t>protects from mass assignment, keeps the user input</a:t>
             </a:r>
           </a:p>
         </p:txBody>
@@ -8824,7 +8824,7 @@
                 </a:solidFill>
                 <a:latin typeface="Calibri"/>
               </a:rPr>
-              <a:t>BindingResult не сразу после формы?</a:t>
+              <a:t>BindingResult not right after the form?</a:t>
             </a:r>
           </a:p>
         </p:txBody>
@@ -8863,7 +8863,7 @@
                 </a:solidFill>
                 <a:latin typeface="Calibri"/>
               </a:rPr>
-              <a:t>исключение и 400 вместо формы с ошибками</a:t>
+              <a:t>an exception and 400 instead of the form with errors</a:t>
             </a:r>
           </a:p>
         </p:txBody>
@@ -8928,7 +8928,7 @@
                 </a:solidFill>
                 <a:latin typeface="Cambria"/>
               </a:rPr>
-              <a:t>Итоги</a:t>
+              <a:t>Summary</a:t>
             </a:r>
           </a:p>
         </p:txBody>
@@ -9020,7 +9020,7 @@
                 </a:solidFill>
                 <a:latin typeface="Calibri"/>
               </a:rPr>
-              <a:t>Одно приложение</a:t>
+              <a:t>One application</a:t>
             </a:r>
           </a:p>
         </p:txBody>
@@ -9059,7 +9059,7 @@
                 </a:solidFill>
                 <a:latin typeface="Calibri"/>
               </a:rPr>
-              <a:t>каталог библиотеки вместо шести отдельных демо</a:t>
+              <a:t>a library catalogue instead of six separate demos</a:t>
             </a:r>
           </a:p>
         </p:txBody>
@@ -9151,7 +9151,7 @@
                 </a:solidFill>
                 <a:latin typeface="Calibri"/>
               </a:rPr>
-              <a:t>Шесть вариантов</a:t>
+              <a:t>Six variants</a:t>
             </a:r>
           </a:p>
         </p:txBody>
@@ -9190,7 +9190,7 @@
                 </a:solidFill>
                 <a:latin typeface="Calibri"/>
               </a:rPr>
-              <a:t>V7 · V8 · V7 · V8 · V6 · V7 — реализованы и связаны</a:t>
+              <a:t>V7 · V8 · V7 · V8 · V6 · V7 — implemented and connected</a:t>
             </a:r>
           </a:p>
         </p:txBody>
@@ -9282,7 +9282,7 @@
                 </a:solidFill>
                 <a:latin typeface="Calibri"/>
               </a:rPr>
-              <a:t>17 тестов</a:t>
+              <a:t>17 tests</a:t>
             </a:r>
           </a:p>
         </p:txBody>
@@ -9321,7 +9321,7 @@
                 </a:solidFill>
                 <a:latin typeface="Calibri"/>
               </a:rPr>
-              <a:t>каждый эксперимент из отчётов воспроизводится</a:t>
+              <a:t>every experiment from the reports is reproduced</a:t>
             </a:r>
           </a:p>
         </p:txBody>
@@ -9360,7 +9360,7 @@
                 </a:solidFill>
                 <a:latin typeface="Calibri"/>
               </a:rPr>
-              <a:t>Спасибо за внимание! Готов ответить на вопросы.</a:t>
+              <a:t>Thank you for your attention! Questions are welcome.</a:t>
             </a:r>
           </a:p>
         </p:txBody>
@@ -9464,7 +9464,7 @@
                 </a:solidFill>
                 <a:latin typeface="Cambria"/>
               </a:rPr>
-              <a:t>Идея: шесть лабораторных как шесть слоёв</a:t>
+              <a:t>The idea: six labs as six layers</a:t>
             </a:r>
           </a:p>
         </p:txBody>
@@ -9503,7 +9503,7 @@
                 </a:solidFill>
                 <a:latin typeface="Calibri"/>
               </a:rPr>
-              <a:t>Library Portal  ·  RWPSF 3305  ·  Бектурсын Куат</a:t>
+              <a:t>Library Portal  ·  RWPSF 3305  ·  Kuat Bektursyn</a:t>
             </a:r>
           </a:p>
         </p:txBody>
@@ -9666,8 +9666,8 @@
                 </a:solidFill>
                 <a:latin typeface="Calibri"/>
               </a:rPr>
-              <a:t>лабораторных работ
-в одном приложении</a:t>
+              <a:t>laboratory works
+in one application</a:t>
             </a:r>
           </a:p>
         </p:txBody>
@@ -9791,8 +9791,8 @@
                 </a:solidFill>
                 <a:latin typeface="Calibri"/>
               </a:rPr>
-              <a:t>интеграционных тестов —
-каждый эксперимент</a:t>
+              <a:t>integration tests —
+one per experiment</a:t>
             </a:r>
           </a:p>
         </p:txBody>
@@ -9916,8 +9916,8 @@
                 </a:solidFill>
                 <a:latin typeface="Calibri"/>
               </a:rPr>
-              <a:t>индивидуальных вариантов
-реализованы</a:t>
+              <a:t>individual variants
+implemented</a:t>
             </a:r>
           </a:p>
         </p:txBody>
@@ -10041,8 +10041,8 @@
                 </a:solidFill>
                 <a:latin typeface="Calibri"/>
               </a:rPr>
-              <a:t>общий BookService
-для всех слоёв</a:t>
+              <a:t>shared BookService
+for every layer</a:t>
             </a:r>
           </a:p>
         </p:txBody>
@@ -10081,7 +10081,7 @@
                 </a:solidFill>
                 <a:latin typeface="Cambria"/>
               </a:rPr>
-              <a:t>Технологии</a:t>
+              <a:t>Technology stack</a:t>
             </a:r>
           </a:p>
         </p:txBody>
@@ -10167,7 +10167,7 @@
                 </a:solidFill>
                 <a:latin typeface="Calibri"/>
               </a:rPr>
-              <a:t>Spring AOP (AspectJ-аннотации), Spring Boot Actuator</a:t>
+              <a:t>Spring AOP (AspectJ annotations), Spring Boot Actuator</a:t>
             </a:r>
           </a:p>
         </p:txBody>
@@ -10206,7 +10206,7 @@
                 </a:solidFill>
                 <a:latin typeface="Cambria"/>
               </a:rPr>
-              <a:t>Предметная область</a:t>
+              <a:t>Domain</a:t>
             </a:r>
           </a:p>
         </p:txBody>
@@ -10250,7 +10250,7 @@
                 </a:solidFill>
                 <a:latin typeface="Calibri"/>
               </a:rPr>
-              <a:t>Каталог книг: список, карточка, добавление, удаление</a:t>
+              <a:t>Book catalogue: list, details, add, delete</a:t>
             </a:r>
           </a:p>
           <a:p>
@@ -10271,7 +10271,7 @@
                 </a:solidFill>
                 <a:latin typeface="Calibri"/>
               </a:rPr>
-              <a:t>REST API /api/books и HTML-страницы /books</a:t>
+              <a:t>REST API /api/books and HTML pages /books</a:t>
             </a:r>
           </a:p>
           <a:p>
@@ -10292,7 +10292,7 @@
                 </a:solidFill>
                 <a:latin typeface="Calibri"/>
               </a:rPr>
-              <a:t>Два языка интерфейса — EN и RU</a:t>
+              <a:t>Two interface languages — EN and RU</a:t>
             </a:r>
           </a:p>
         </p:txBody>
@@ -10357,7 +10357,7 @@
                 </a:solidFill>
                 <a:latin typeface="Cambria"/>
               </a:rPr>
-              <a:t>Архитектура: где живёт каждая лабораторная</a:t>
+              <a:t>Architecture: where each lab lives</a:t>
             </a:r>
           </a:p>
         </p:txBody>
@@ -10396,7 +10396,7 @@
                 </a:solidFill>
                 <a:latin typeface="Calibri"/>
               </a:rPr>
-              <a:t>Library Portal  ·  RWPSF 3305  ·  Бектурсын Куат</a:t>
+              <a:t>Library Portal  ·  RWPSF 3305  ·  Kuat Bektursyn</a:t>
             </a:r>
           </a:p>
         </p:txBody>
@@ -11051,7 +11051,7 @@
                 </a:solidFill>
                 <a:latin typeface="Calibri"/>
               </a:rPr>
-              <a:t>CGLIB-прокси BookService</a:t>
+              <a:t>CGLIB proxy of BookService</a:t>
             </a:r>
           </a:p>
         </p:txBody>
@@ -12204,7 +12204,7 @@
                 </a:solidFill>
                 <a:latin typeface="Cambria"/>
               </a:rPr>
-              <a:t>Spring Boot и первый REST-контроллер</a:t>
+              <a:t>Spring Boot and the first REST controller</a:t>
             </a:r>
           </a:p>
         </p:txBody>
@@ -12289,7 +12289,7 @@
                 </a:solidFill>
                 <a:latin typeface="Calibri"/>
               </a:rPr>
-              <a:t>Лаб. 1  ·  V7</a:t>
+              <a:t>Lab 1  ·  V7</a:t>
             </a:r>
           </a:p>
         </p:txBody>
@@ -12328,7 +12328,7 @@
                 </a:solidFill>
                 <a:latin typeface="Calibri"/>
               </a:rPr>
-              <a:t>Library Portal  ·  RWPSF 3305  ·  Бектурсын Куат</a:t>
+              <a:t>Library Portal  ·  RWPSF 3305  ·  Kuat Bektursyn</a:t>
             </a:r>
           </a:p>
         </p:txBody>
@@ -12411,7 +12411,7 @@
                 </a:solidFill>
                 <a:latin typeface="Calibri"/>
               </a:rPr>
-              <a:t>Проект: </a:t>
+              <a:t>Project: </a:t>
             </a:r>
             <a:r>
               <a:rPr sz="1500" b="0">
@@ -12441,7 +12441,7 @@
                 </a:solidFill>
                 <a:latin typeface="Calibri"/>
               </a:rPr>
-              <a:t>Стартеры: </a:t>
+              <a:t>Starters: </a:t>
             </a:r>
             <a:r>
               <a:rPr sz="1500" b="0">
@@ -12450,7 +12450,7 @@
                 </a:solidFill>
                 <a:latin typeface="Calibri"/>
               </a:rPr>
-              <a:t>webmvc (Tomcat, Jackson транзитивно), DevTools</a:t>
+              <a:t>webmvc (Tomcat and Jackson come transitively), DevTools</a:t>
             </a:r>
           </a:p>
           <a:p>
@@ -12501,7 +12501,7 @@
                 </a:solidFill>
                 <a:latin typeface="Calibri"/>
               </a:rPr>
-              <a:t>Эндпоинты: </a:t>
+              <a:t>Endpoints: </a:t>
             </a:r>
             <a:r>
               <a:rPr sz="1500" b="0">
@@ -12531,7 +12531,7 @@
                 </a:solidFill>
                 <a:latin typeface="Calibri"/>
               </a:rPr>
-              <a:t>Вариант 7: </a:t>
+              <a:t>Variant 7: </a:t>
             </a:r>
             <a:r>
               <a:rPr sz="1500" b="0">
@@ -12540,7 +12540,7 @@
                 </a:solidFill>
                 <a:latin typeface="Calibri"/>
               </a:rPr>
-              <a:t>/api/wordcount — слова, символы, самое длинное слово</a:t>
+              <a:t>/api/wordcount — words, characters, longest word</a:t>
             </a:r>
           </a:p>
         </p:txBody>
@@ -12842,7 +12842,7 @@
                           </a:solidFill>
                           <a:latin typeface="Calibri"/>
                         </a:rPr>
-                        <a:t>Ввод text</a:t>
+                        <a:t>Input text</a:t>
                       </a:r>
                     </a:p>
                   </a:txBody>
@@ -13112,7 +13112,7 @@
                           </a:solidFill>
                           <a:latin typeface="Calibri"/>
                         </a:rPr>
-                        <a:t>(параметр не передан)</a:t>
+                        <a:t>(parameter omitted)</a:t>
                       </a:r>
                     </a:p>
                   </a:txBody>
@@ -13253,7 +13253,7 @@
                 </a:solidFill>
                 <a:latin typeface="Cambria"/>
               </a:rPr>
-              <a:t>IoC-контейнер: бины, внедрение, скоупы</a:t>
+              <a:t>IoC container: beans, injection, scopes</a:t>
             </a:r>
           </a:p>
         </p:txBody>
@@ -13338,7 +13338,7 @@
                 </a:solidFill>
                 <a:latin typeface="Calibri"/>
               </a:rPr>
-              <a:t>Лаб. 2  ·  V8</a:t>
+              <a:t>Lab 2  ·  V8</a:t>
             </a:r>
           </a:p>
         </p:txBody>
@@ -13377,7 +13377,7 @@
                 </a:solidFill>
                 <a:latin typeface="Calibri"/>
               </a:rPr>
-              <a:t>Library Portal  ·  RWPSF 3305  ·  Бектурсын Куат</a:t>
+              <a:t>Library Portal  ·  RWPSF 3305  ·  Kuat Bektursyn</a:t>
             </a:r>
           </a:p>
         </p:txBody>
@@ -13979,7 +13979,7 @@
                 </a:solidFill>
                 <a:latin typeface="Calibri"/>
               </a:rPr>
-              <a:t>List&lt;Notifier&gt; упорядочен по @Order: console → email → html → noop</a:t>
+              <a:t>List&lt;Notifier&gt; is ordered by @Order: console → email → html → noop</a:t>
             </a:r>
           </a:p>
         </p:txBody>
@@ -14032,7 +14032,7 @@
                 </a:solidFill>
                 <a:latin typeface="Calibri"/>
               </a:rPr>
-              <a:t> — 4 способа выбрать бин</a:t>
+              <a:t> — 4 ways to pick a bean</a:t>
             </a:r>
           </a:p>
           <a:p>
@@ -14062,7 +14062,7 @@
                 </a:solidFill>
                 <a:latin typeface="Calibri"/>
               </a:rPr>
-              <a:t> — класс JDK без @Component</a:t>
+              <a:t> — a JDK class without @Component</a:t>
             </a:r>
           </a:p>
           <a:p>
@@ -14092,7 +14092,7 @@
                 </a:solidFill>
                 <a:latin typeface="Calibri"/>
               </a:rPr>
-              <a:t> конструктор → @PostConstruct → @PreDestroy</a:t>
+              <a:t> constructor → @PostConstruct → @PreDestroy</a:t>
             </a:r>
           </a:p>
           <a:p>
@@ -14122,7 +14122,7 @@
                 </a:solidFill>
                 <a:latin typeface="Calibri"/>
               </a:rPr>
-              <a:t> новый экземпляр только через ObjectProvider</a:t>
+              <a:t> a new instance only through ObjectProvider</a:t>
             </a:r>
           </a:p>
         </p:txBody>
@@ -14207,7 +14207,7 @@
                 </a:solidFill>
                 <a:latin typeface="Calibri"/>
               </a:rPr>
-              <a:t>Вариант 8 · HtmlNotifier</a:t>
+              <a:t>Variant 8 · HtmlNotifier</a:t>
             </a:r>
           </a:p>
         </p:txBody>
@@ -14246,7 +14246,7 @@
                 </a:solidFill>
                 <a:latin typeface="Calibri"/>
               </a:rPr>
-              <a:t>вход:  </a:t>
+              <a:t>input:  </a:t>
             </a:r>
             <a:r>
               <a:rPr sz="1400" b="0" i="0">
@@ -14271,7 +14271,7 @@
                 </a:solidFill>
                 <a:latin typeface="Calibri"/>
               </a:rPr>
-              <a:t>выход: </a:t>
+              <a:t>output: </a:t>
             </a:r>
             <a:r>
               <a:rPr sz="1400" b="0" i="0">
@@ -14296,7 +14296,7 @@
                 </a:solidFill>
                 <a:latin typeface="Calibri"/>
               </a:rPr>
-              <a:t>Угловые скобки экранируются, а не интерпретируются как HTML</a:t>
+              <a:t>Angle brackets are escaped instead of being interpreted as HTML</a:t>
             </a:r>
           </a:p>
         </p:txBody>
@@ -14381,7 +14381,7 @@
                 </a:solidFill>
                 <a:latin typeface="Calibri"/>
               </a:rPr>
-              <a:t>Связь с проектом</a:t>
+              <a:t>How it is used in the project</a:t>
             </a:r>
           </a:p>
         </p:txBody>
@@ -14420,7 +14420,7 @@
                 </a:solidFill>
                 <a:latin typeface="Calibri"/>
               </a:rPr>
-              <a:t>BookService.create() отправляет «New book in the catalogue» через @Primary EmailNotifier, который читает app.mail.* из лабораторной 3</a:t>
+              <a:t>BookService.create() sends «New book in the catalogue» through the @Primary EmailNotifier, which reads app.mail.* from lab 3</a:t>
             </a:r>
           </a:p>
         </p:txBody>
@@ -14485,7 +14485,7 @@
                 </a:solidFill>
                 <a:latin typeface="Cambria"/>
               </a:rPr>
-              <a:t>Конфигурация: YAML, профили, свойства</a:t>
+              <a:t>Configuration: YAML, profiles, properties</a:t>
             </a:r>
           </a:p>
         </p:txBody>
@@ -14570,7 +14570,7 @@
                 </a:solidFill>
                 <a:latin typeface="Calibri"/>
               </a:rPr>
-              <a:t>Лаб. 3  ·  V7</a:t>
+              <a:t>Lab 3  ·  V7</a:t>
             </a:r>
           </a:p>
         </p:txBody>
@@ -14609,7 +14609,7 @@
                 </a:solidFill>
                 <a:latin typeface="Calibri"/>
               </a:rPr>
-              <a:t>Library Portal  ·  RWPSF 3305  ·  Бектурсын Куат</a:t>
+              <a:t>Library Portal  ·  RWPSF 3305  ·  Kuat Bektursyn</a:t>
             </a:r>
           </a:p>
         </p:txBody>
@@ -14690,7 +14690,7 @@
                           </a:solidFill>
                           <a:latin typeface="Calibri"/>
                         </a:rPr>
-                        <a:t>Поле /api/config</a:t>
+                        <a:t>/api/config field</a:t>
                       </a:r>
                     </a:p>
                   </a:txBody>
@@ -14712,7 +14712,7 @@
                           </a:solidFill>
                           <a:latin typeface="Calibri"/>
                         </a:rPr>
-                        <a:t>без профиля</a:t>
+                        <a:t>no profile</a:t>
                       </a:r>
                     </a:p>
                   </a:txBody>
@@ -15345,7 +15345,7 @@
                 </a:solidFill>
                 <a:latin typeface="Calibri"/>
               </a:rPr>
-              <a:t>Приоритет источников (сильнее → слабее)</a:t>
+              <a:t>Property source precedence (strongest → weakest)</a:t>
             </a:r>
           </a:p>
         </p:txBody>
@@ -16181,7 +16181,7 @@
                 </a:solidFill>
                 <a:latin typeface="Calibri"/>
               </a:rPr>
-              <a:t>/actuator/env/app.mail.retry-count показывает значение и источник</a:t>
+              <a:t>/actuator/env/app.mail.retry-count shows the value and its source</a:t>
             </a:r>
           </a:p>
           <a:p>
@@ -16197,7 +16197,7 @@
                 </a:solidFill>
                 <a:latin typeface="Calibri"/>
               </a:rPr>
-              <a:t>Проверка: </a:t>
+              <a:t>Check: </a:t>
             </a:r>
             <a:r>
               <a:rPr sz="1300" b="0" i="0">
@@ -16271,7 +16271,7 @@
                 </a:solidFill>
                 <a:latin typeface="Cambria"/>
               </a:rPr>
-              <a:t>Spring AOP: сквозная функциональность</a:t>
+              <a:t>Spring AOP: cross-cutting concerns</a:t>
             </a:r>
           </a:p>
         </p:txBody>
@@ -16356,7 +16356,7 @@
                 </a:solidFill>
                 <a:latin typeface="Calibri"/>
               </a:rPr>
-              <a:t>Лаб. 4  ·  V8</a:t>
+              <a:t>Lab 4  ·  V8</a:t>
             </a:r>
           </a:p>
         </p:txBody>
@@ -16395,7 +16395,7 @@
                 </a:solidFill>
                 <a:latin typeface="Calibri"/>
               </a:rPr>
-              <a:t>Library Portal  ·  RWPSF 3305  ·  Бектурсын Куат</a:t>
+              <a:t>Library Portal  ·  RWPSF 3305  ·  Kuat Bektursyn</a:t>
             </a:r>
           </a:p>
         </p:txBody>
@@ -16813,7 +16813,7 @@
                 </a:solidFill>
                 <a:latin typeface="Courier New"/>
               </a:rPr>
-              <a:t>CGLIB-прокси:
+              <a:t>CGLIB proxy:
 BookService$$SpringCGLIB$$1</a:t>
             </a:r>
           </a:p>
@@ -16876,7 +16876,7 @@
                           </a:solidFill>
                           <a:latin typeface="Calibri"/>
                         </a:rPr>
-                        <a:t>Записей BOOK_DELETE</a:t>
+                        <a:t>BOOK_DELETE records</a:t>
                       </a:r>
                     </a:p>
                   </a:txBody>
@@ -16922,7 +16922,7 @@
                           </a:solidFill>
                           <a:latin typeface="Calibri"/>
                         </a:rPr>
-                        <a:t>0  (обход прокси)</a:t>
+                        <a:t>0  (proxy bypassed)</a:t>
                       </a:r>
                     </a:p>
                   </a:txBody>
@@ -16968,7 +16968,7 @@
                           </a:solidFill>
                           <a:latin typeface="Calibri"/>
                         </a:rPr>
-                        <a:t>2  (через прокси)</a:t>
+                        <a:t>2  (through the proxy)</a:t>
                       </a:r>
                     </a:p>
                   </a:txBody>
@@ -17063,7 +17063,7 @@
                 </a:solidFill>
                 <a:latin typeface="Calibri"/>
               </a:rPr>
-              <a:t>Реальный лог · deleteBulk(viaProxy=true)</a:t>
+              <a:t>Real log · deleteBulk(viaProxy=true)</a:t>
             </a:r>
           </a:p>
         </p:txBody>
@@ -17370,7 +17370,7 @@
                 </a:solidFill>
                 <a:latin typeface="Calibri"/>
               </a:rPr>
-              <a:t>@Before увеличивает, @After уменьшает глубину в ThreadLocal — отступ показывает вложенность</a:t>
+              <a:t>@Before increases and @After decreases the ThreadLocal depth — the indent shows the nesting</a:t>
             </a:r>
           </a:p>
         </p:txBody>
@@ -17435,7 +17435,7 @@
                 </a:solidFill>
                 <a:latin typeface="Cambria"/>
               </a:rPr>
-              <a:t>Spring MVC: маршрутизация и коды ответа</a:t>
+              <a:t>Spring MVC: routing and status codes</a:t>
             </a:r>
           </a:p>
         </p:txBody>
@@ -17520,7 +17520,7 @@
                 </a:solidFill>
                 <a:latin typeface="Calibri"/>
               </a:rPr>
-              <a:t>Лаб. 5  ·  V6</a:t>
+              <a:t>Lab 5  ·  V6</a:t>
             </a:r>
           </a:p>
         </p:txBody>
@@ -17559,7 +17559,7 @@
                 </a:solidFill>
                 <a:latin typeface="Calibri"/>
               </a:rPr>
-              <a:t>Library Portal  ·  RWPSF 3305  ·  Бектурсын Куат</a:t>
+              <a:t>Library Portal  ·  RWPSF 3305  ·  Kuat Bektursyn</a:t>
             </a:r>
           </a:p>
         </p:txBody>
@@ -17761,7 +17761,7 @@
                 </a:solidFill>
                 <a:latin typeface="Calibri"/>
               </a:rPr>
-              <a:t>список, ?author, ?limit</a:t>
+              <a:t>list, ?author, ?limit</a:t>
             </a:r>
           </a:p>
         </p:txBody>
@@ -18087,7 +18087,7 @@
                 </a:solidFill>
                 <a:latin typeface="Calibri"/>
               </a:rPr>
-              <a:t>удалено</a:t>
+              <a:t>deleted</a:t>
             </a:r>
           </a:p>
         </p:txBody>
@@ -18213,7 +18213,7 @@
                 </a:solidFill>
                 <a:latin typeface="Courier New"/>
               </a:rPr>
-              <a:t>DELETE ещё раз</a:t>
+              <a:t>DELETE again</a:t>
             </a:r>
           </a:p>
         </p:txBody>
@@ -18252,7 +18252,7 @@
                 </a:solidFill>
                 <a:latin typeface="Calibri"/>
               </a:rPr>
-              <a:t>уже нет</a:t>
+              <a:t>already gone</a:t>
             </a:r>
           </a:p>
         </p:txBody>
@@ -18417,7 +18417,7 @@
                 </a:solidFill>
                 <a:latin typeface="Calibri"/>
               </a:rPr>
-              <a:t>abc → long</a:t>
+              <a:t>abc → long fails</a:t>
             </a:r>
           </a:p>
         </p:txBody>
@@ -18582,7 +18582,7 @@
                 </a:solidFill>
                 <a:latin typeface="Calibri"/>
               </a:rPr>
-              <a:t>метод не тот</a:t>
+              <a:t>wrong method</a:t>
             </a:r>
           </a:p>
         </p:txBody>
@@ -18747,7 +18747,7 @@
                 </a:solidFill>
                 <a:latin typeface="Calibri"/>
               </a:rPr>
-              <a:t>тип тела</a:t>
+              <a:t>body media type</a:t>
             </a:r>
           </a:p>
         </p:txBody>
@@ -18912,7 +18912,7 @@
                 </a:solidFill>
                 <a:latin typeface="Calibri"/>
               </a:rPr>
-              <a:t>тип ответа</a:t>
+              <a:t>response media type</a:t>
             </a:r>
           </a:p>
         </p:txBody>
@@ -18956,7 +18956,7 @@
                 </a:solidFill>
                 <a:latin typeface="Calibri"/>
               </a:rPr>
-              <a:t>@RestController пишет в тело ответа, @Controller возвращает имя шаблона</a:t>
+              <a:t>@RestController writes to the response body, @Controller returns a view name</a:t>
             </a:r>
           </a:p>
           <a:p>
@@ -18977,7 +18977,7 @@
                 </a:solidFill>
                 <a:latin typeface="Calibri"/>
               </a:rPr>
-              <a:t>Post/Redirect/Get + flash: после F5 нет дубля</a:t>
+              <a:t>Post/Redirect/Get + flash: no duplicate after F5</a:t>
             </a:r>
           </a:p>
           <a:p>
@@ -18998,7 +18998,7 @@
                 </a:solidFill>
                 <a:latin typeface="Calibri"/>
               </a:rPr>
-              <a:t>static/index.html и css/app.css — без контроллера</a:t>
+              <a:t>static/index.html and css/app.css — served without a controller</a:t>
             </a:r>
           </a:p>
         </p:txBody>
@@ -19083,7 +19083,7 @@
                 </a:solidFill>
                 <a:latin typeface="Calibri"/>
               </a:rPr>
-              <a:t>Вариант 6 · цитата</a:t>
+              <a:t>Variant 6 · citation</a:t>
             </a:r>
           </a:p>
         </p:txBody>
@@ -19228,7 +19228,7 @@
                 </a:solidFill>
                 <a:latin typeface="Cambria"/>
               </a:rPr>
-              <a:t>Формы, валидация и обработка ошибок</a:t>
+              <a:t>Forms, validation and error handling</a:t>
             </a:r>
           </a:p>
         </p:txBody>
@@ -19313,7 +19313,7 @@
                 </a:solidFill>
                 <a:latin typeface="Calibri"/>
               </a:rPr>
-              <a:t>Лаб. 6  ·  V7</a:t>
+              <a:t>Lab 6  ·  V7</a:t>
             </a:r>
           </a:p>
         </p:txBody>
@@ -19352,7 +19352,7 @@
                 </a:solidFill>
                 <a:latin typeface="Calibri"/>
               </a:rPr>
-              <a:t>Library Portal  ·  RWPSF 3305  ·  Бектурсын Куат</a:t>
+              <a:t>Library Portal  ·  RWPSF 3305  ·  Kuat Bektursyn</a:t>
             </a:r>
           </a:p>
         </p:txBody>
@@ -19483,7 +19483,7 @@
                 </a:solidFill>
                 <a:latin typeface="Calibri"/>
               </a:rPr>
-              <a:t>Браузер</a:t>
+              <a:t>Browser</a:t>
             </a:r>
           </a:p>
         </p:txBody>
@@ -20194,8 +20194,8 @@
                 </a:solidFill>
                 <a:latin typeface="Calibri"/>
               </a:rPr>
-              <a:t>ошибки, без
-исключения</a:t>
+              <a:t>errors, no
+exception</a:t>
             </a:r>
           </a:p>
         </p:txBody>
@@ -20448,7 +20448,7 @@
                 </a:solidFill>
                 <a:latin typeface="Calibri"/>
               </a:rPr>
-              <a:t>Вариант 7 · дата публикации</a:t>
+              <a:t>Variant 7 · publication date</a:t>
             </a:r>
           </a:p>
         </p:txBody>
@@ -20560,7 +20560,7 @@
                           </a:solidFill>
                           <a:latin typeface="Calibri"/>
                         </a:rPr>
-                        <a:t>Локаль</a:t>
+                        <a:t>Locale</a:t>
                       </a:r>
                     </a:p>
                   </a:txBody>
@@ -20582,7 +20582,7 @@
                           </a:solidFill>
                           <a:latin typeface="Calibri"/>
                         </a:rPr>
-                        <a:t>Ввод</a:t>
+                        <a:t>Input</a:t>
                       </a:r>
                     </a:p>
                   </a:txBody>
@@ -20604,7 +20604,7 @@
                           </a:solidFill>
                           <a:latin typeface="Calibri"/>
                         </a:rPr>
-                        <a:t>В каталоге</a:t>
+                        <a:t>In the catalogue</a:t>
                       </a:r>
                     </a:p>
                   </a:txBody>
@@ -20803,7 +20803,7 @@
                 </a:solidFill>
                 <a:latin typeface="Calibri"/>
               </a:rPr>
-              <a:t>отдельно от record Book — нет id, нет mass assignment</a:t>
+              <a:t>is separate from the Book record — no id, no mass assignment</a:t>
             </a:r>
           </a:p>
           <a:p>
@@ -20833,7 +20833,7 @@
                 </a:solidFill>
                 <a:latin typeface="Calibri"/>
               </a:rPr>
-              <a:t>— своё ограничение; null валиден</a:t>
+              <a:t>— a custom constraint; null is valid</a:t>
             </a:r>
           </a:p>
           <a:p>
@@ -20863,7 +20863,7 @@
                 </a:solidFill>
                 <a:latin typeface="Calibri"/>
               </a:rPr>
-              <a:t>+ ?lang=ru через SessionLocaleResolver</a:t>
+              <a:t>+ ?lang=ru via SessionLocaleResolver</a:t>
             </a:r>
           </a:p>
           <a:p>
@@ -20893,7 +20893,7 @@
                 </a:solidFill>
                 <a:latin typeface="Calibri"/>
               </a:rPr>
-              <a:t>→ HTML-страница 404 (PageExceptionHandler)</a:t>
+              <a:t>→ HTML 404 page (PageExceptionHandler)</a:t>
             </a:r>
           </a:p>
           <a:p>

</xml_diff>